<commit_message>
Add references slide to SPbU light-theme presentation
Co-Authored-By: Claude Opus 5.5 <noreply@anthropic.com>
Claude-Session: https://claude.ai/code/session_01UdtXbLja44rJqF7YujNZYC
</commit_message>
<xml_diff>
--- a/spbgu-hydromin/Презентация_СПбГУ_светлая_тема.pptx
+++ b/spbgu-hydromin/Презентация_СПбГУ_светлая_тема.pptx
@@ -23,6 +23,7 @@
     <p:sldId id="269" r:id="rId22"/>
     <p:sldId id="270" r:id="rId23"/>
     <p:sldId id="271" r:id="rId24"/>
+    <p:sldId id="272" r:id="rId25"/>
   </p:sldIdLst>
   <p:sldSz cx="12192000" cy="6858000"/>
   <p:notesSz cx="6858000" cy="9144000"/>
@@ -2466,6 +2467,76 @@
 </p:notes>
 </file>
 
+<file path=ppt/notesSlides/notesSlide17.xml><?xml version="1.0" encoding="utf-8"?>
+<p:notes xmlns:a="http://schemas.openxmlformats.org/drawingml/2006/main" xmlns:p="http://schemas.openxmlformats.org/presentationml/2006/main" xmlns:r="http://schemas.openxmlformats.org/officeDocument/2006/relationships">
+  <p:cSld>
+    <p:spTree>
+      <p:nvGrpSpPr>
+        <p:cNvPr id="1" name=""/>
+        <p:cNvGrpSpPr/>
+        <p:nvPr/>
+      </p:nvGrpSpPr>
+      <p:grpSpPr>
+        <a:xfrm>
+          <a:off x="0" y="0"/>
+          <a:ext cx="0" cy="0"/>
+          <a:chOff x="0" y="0"/>
+          <a:chExt cx="0" cy="0"/>
+        </a:xfrm>
+      </p:grpSpPr>
+      <p:sp>
+        <p:nvSpPr>
+          <p:cNvPr id="2" name="Slide Image Placeholder 1"/>
+          <p:cNvSpPr>
+            <a:spLocks noGrp="1"/>
+          </p:cNvSpPr>
+          <p:nvPr>
+            <p:ph type="sldImg" idx="2"/>
+          </p:nvPr>
+        </p:nvSpPr>
+        <p:spPr/>
+      </p:sp>
+      <p:sp>
+        <p:nvSpPr>
+          <p:cNvPr id="3" name="Notes Placeholder 2"/>
+          <p:cNvSpPr>
+            <a:spLocks noGrp="1"/>
+          </p:cNvSpPr>
+          <p:nvPr>
+            <p:ph type="body" idx="3" sz="quarter"/>
+          </p:nvPr>
+        </p:nvSpPr>
+        <p:spPr/>
+        <p:txBody>
+          <a:bodyPr/>
+          <a:lstStyle/>
+          <a:p>
+            <a:r>
+              <a:t>Список литературы, на которую я ссылалась в докладе. Полный список источников приведен в тексте статьи.</a:t>
+            </a:r>
+          </a:p>
+        </p:txBody>
+      </p:sp>
+      <p:sp>
+        <p:nvSpPr>
+          <p:cNvPr id="4" name="Slide Number Placeholder 3"/>
+          <p:cNvSpPr>
+            <a:spLocks noGrp="1"/>
+          </p:cNvSpPr>
+          <p:nvPr>
+            <p:ph type="sldNum" idx="5" sz="quarter"/>
+          </p:nvPr>
+        </p:nvSpPr>
+        <p:spPr/>
+      </p:sp>
+    </p:spTree>
+  </p:cSld>
+  <p:clrMapOvr>
+    <a:masterClrMapping/>
+  </p:clrMapOvr>
+</p:notes>
+</file>
+
 <file path=ppt/notesSlides/notesSlide2.xml><?xml version="1.0" encoding="utf-8"?>
 <p:notes xmlns:a="http://schemas.openxmlformats.org/drawingml/2006/main" xmlns:p="http://schemas.openxmlformats.org/presentationml/2006/main" xmlns:r="http://schemas.openxmlformats.org/officeDocument/2006/relationships">
   <p:cSld>
@@ -5586,7 +5657,7 @@
                 </a:solidFill>
                 <a:latin typeface="Open Sans"/>
               </a:rPr>
-              <a:t>10 / 16</a:t>
+              <a:t>10 / 17</a:t>
             </a:r>
           </a:p>
         </p:txBody>
@@ -7446,7 +7517,7 @@
                 </a:solidFill>
                 <a:latin typeface="Open Sans"/>
               </a:rPr>
-              <a:t>11 / 16</a:t>
+              <a:t>11 / 17</a:t>
             </a:r>
           </a:p>
         </p:txBody>
@@ -8175,7 +8246,7 @@
                 </a:solidFill>
                 <a:latin typeface="Open Sans"/>
               </a:rPr>
-              <a:t>12 / 16</a:t>
+              <a:t>12 / 17</a:t>
             </a:r>
           </a:p>
         </p:txBody>
@@ -8519,7 +8590,7 @@
                 </a:solidFill>
                 <a:latin typeface="Open Sans"/>
               </a:rPr>
-              <a:t>13 / 16</a:t>
+              <a:t>13 / 17</a:t>
             </a:r>
           </a:p>
         </p:txBody>
@@ -9762,7 +9833,7 @@
                 </a:solidFill>
                 <a:latin typeface="Open Sans"/>
               </a:rPr>
-              <a:t>14 / 16</a:t>
+              <a:t>14 / 17</a:t>
             </a:r>
           </a:p>
         </p:txBody>
@@ -11033,7 +11104,7 @@
                 </a:solidFill>
                 <a:latin typeface="Open Sans"/>
               </a:rPr>
-              <a:t>15 / 16</a:t>
+              <a:t>15 / 17</a:t>
             </a:r>
           </a:p>
         </p:txBody>
@@ -11822,6 +11893,392 @@
 </p:sld>
 </file>
 
+<file path=ppt/slides/slide17.xml><?xml version="1.0" encoding="utf-8"?>
+<p:sld xmlns:a="http://schemas.openxmlformats.org/drawingml/2006/main" xmlns:p="http://schemas.openxmlformats.org/presentationml/2006/main" xmlns:r="http://schemas.openxmlformats.org/officeDocument/2006/relationships">
+  <p:cSld>
+    <p:spTree>
+      <p:nvGrpSpPr>
+        <p:cNvPr id="1" name=""/>
+        <p:cNvGrpSpPr/>
+        <p:nvPr/>
+      </p:nvGrpSpPr>
+      <p:grpSpPr/>
+      <p:sp>
+        <p:nvSpPr>
+          <p:cNvPr id="2" name="TextBox 1"/>
+          <p:cNvSpPr txBox="1"/>
+          <p:nvPr/>
+        </p:nvSpPr>
+        <p:spPr>
+          <a:xfrm>
+            <a:off x="548640" y="1261872"/>
+            <a:ext cx="11091672" cy="640080"/>
+          </a:xfrm>
+          <a:prstGeom prst="rect">
+            <a:avLst/>
+          </a:prstGeom>
+          <a:noFill/>
+        </p:spPr>
+        <p:txBody>
+          <a:bodyPr wrap="square" lIns="0" rIns="0" tIns="0" bIns="0" anchor="t"/>
+          <a:lstStyle/>
+          <a:p>
+            <a:pPr algn="l"/>
+            <a:r>
+              <a:rPr sz="2400" b="1" i="0">
+                <a:solidFill>
+                  <a:srgbClr val="C00000"/>
+                </a:solidFill>
+                <a:latin typeface="Open Sans"/>
+              </a:rPr>
+              <a:t>Список литературы</a:t>
+            </a:r>
+          </a:p>
+        </p:txBody>
+      </p:sp>
+      <p:sp>
+        <p:nvSpPr>
+          <p:cNvPr id="3" name="TextBox 2"/>
+          <p:cNvSpPr txBox="1"/>
+          <p:nvPr/>
+        </p:nvSpPr>
+        <p:spPr>
+          <a:xfrm>
+            <a:off x="548640" y="6382512"/>
+            <a:ext cx="1371600" cy="228600"/>
+          </a:xfrm>
+          <a:prstGeom prst="rect">
+            <a:avLst/>
+          </a:prstGeom>
+          <a:noFill/>
+        </p:spPr>
+        <p:txBody>
+          <a:bodyPr wrap="square" lIns="0" rIns="0" tIns="0" bIns="0" anchor="t"/>
+          <a:lstStyle/>
+          <a:p>
+            <a:pPr algn="l"/>
+            <a:r>
+              <a:rPr sz="1000" b="0" i="0">
+                <a:solidFill>
+                  <a:srgbClr val="8C8C8C"/>
+                </a:solidFill>
+                <a:latin typeface="Open Sans"/>
+              </a:rPr>
+              <a:t>17 / 17</a:t>
+            </a:r>
+          </a:p>
+        </p:txBody>
+      </p:sp>
+      <p:sp>
+        <p:nvSpPr>
+          <p:cNvPr id="4" name="TextBox 3"/>
+          <p:cNvSpPr txBox="1"/>
+          <p:nvPr/>
+        </p:nvSpPr>
+        <p:spPr>
+          <a:xfrm>
+            <a:off x="548640" y="1874519"/>
+            <a:ext cx="5362956" cy="3977639"/>
+          </a:xfrm>
+          <a:prstGeom prst="rect">
+            <a:avLst/>
+          </a:prstGeom>
+          <a:noFill/>
+        </p:spPr>
+        <p:txBody>
+          <a:bodyPr wrap="square" lIns="0" rIns="0" tIns="0" bIns="0">
+            <a:spAutoFit/>
+          </a:bodyPr>
+          <a:lstStyle/>
+          <a:p>
+            <a:pPr marL="274320" indent="-274320">
+              <a:spcAft>
+                <a:spcPts val="300"/>
+              </a:spcAft>
+            </a:pPr>
+            <a:r>
+              <a:rPr sz="900" b="0" i="0">
+                <a:solidFill>
+                  <a:srgbClr val="262626"/>
+                </a:solidFill>
+                <a:latin typeface="Open Sans"/>
+              </a:rPr>
+              <a:t>1.	Бандалетова А. А., Гаврилов А. Ю., Галин Е. В. Извлечение лития из попутных вод на примере Оренбургского НГКМ // PROНЕФТЬ. Профессионально о нефти. 2021. Т. 6, № 1. С. 29–32.</a:t>
+            </a:r>
+          </a:p>
+          <a:p>
+            <a:pPr marL="274320" indent="-274320">
+              <a:spcAft>
+                <a:spcPts val="300"/>
+              </a:spcAft>
+            </a:pPr>
+            <a:r>
+              <a:rPr sz="900" b="0" i="0">
+                <a:solidFill>
+                  <a:srgbClr val="262626"/>
+                </a:solidFill>
+                <a:latin typeface="Open Sans"/>
+              </a:rPr>
+              <a:t>2.	Болдырев В. В., Буйнов Н. М., Вахромеев А. Г., Коцупало Н. П. и др. Литиеносные поликомпонентные глубинные рассолы гидроминеральной провинции Сибирской платформы и их использование в качестве сырьевой базы для создания новых производств в Иркутской области // Вестник Российской академии наук. 2025. № 9. С. 16–26.</a:t>
+            </a:r>
+          </a:p>
+          <a:p>
+            <a:pPr marL="274320" indent="-274320">
+              <a:spcAft>
+                <a:spcPts val="300"/>
+              </a:spcAft>
+            </a:pPr>
+            <a:r>
+              <a:rPr sz="900" b="0" i="0">
+                <a:solidFill>
+                  <a:srgbClr val="262626"/>
+                </a:solidFill>
+                <a:latin typeface="Open Sans"/>
+              </a:rPr>
+              <a:t>3.	Коцупало Н. П. Перспективы получения соединений лития из природных хлоридных рассолов // Химия в интересах устойчивого развития. 2001. Т. 9. С. 243–253.</a:t>
+            </a:r>
+          </a:p>
+          <a:p>
+            <a:pPr marL="274320" indent="-274320">
+              <a:spcAft>
+                <a:spcPts val="300"/>
+              </a:spcAft>
+            </a:pPr>
+            <a:r>
+              <a:rPr sz="900" b="0" i="0">
+                <a:solidFill>
+                  <a:srgbClr val="262626"/>
+                </a:solidFill>
+                <a:latin typeface="Open Sans"/>
+              </a:rPr>
+              <a:t>4.	Менжерес Л. Т., Рябцев А. Д., Мамылова Е. В. Селективный сорбент для извлечения лития из хлоридных высокоминерализованных рассолов // Известия Томского политехнического университета. 2004. Т. 307, № 7. С. 76–80.</a:t>
+            </a:r>
+          </a:p>
+          <a:p>
+            <a:pPr marL="274320" indent="-274320">
+              <a:spcAft>
+                <a:spcPts val="300"/>
+              </a:spcAft>
+            </a:pPr>
+            <a:r>
+              <a:rPr sz="900" b="0" i="0">
+                <a:solidFill>
+                  <a:srgbClr val="262626"/>
+                </a:solidFill>
+                <a:latin typeface="Open Sans"/>
+              </a:rPr>
+              <a:t>5.	Михеева Е. Д., Егоров Я. А. К вопросу о содержаниях лития и попутных компонентов в подземных водах перспективных площадей территории России // Недропользование XXI век. 2022. № 2 (94). С. 29–35.</a:t>
+            </a:r>
+          </a:p>
+          <a:p>
+            <a:pPr marL="274320" indent="-274320">
+              <a:spcAft>
+                <a:spcPts val="300"/>
+              </a:spcAft>
+            </a:pPr>
+            <a:r>
+              <a:rPr sz="900" b="0" i="0">
+                <a:solidFill>
+                  <a:srgbClr val="262626"/>
+                </a:solidFill>
+                <a:latin typeface="Open Sans"/>
+              </a:rPr>
+              <a:t>6.	Первойкин М. В., Зелинская Е. В. Извлечение металлов из высококонцентрированных сточных вод Ковыктинского месторождения // Вестник Кузбасского государственного технического университета. 2022. № 4 (152). С. 59–66.</a:t>
+            </a:r>
+          </a:p>
+          <a:p>
+            <a:pPr marL="274320" indent="-274320">
+              <a:spcAft>
+                <a:spcPts val="300"/>
+              </a:spcAft>
+            </a:pPr>
+            <a:r>
+              <a:rPr sz="900" b="0" i="0">
+                <a:solidFill>
+                  <a:srgbClr val="262626"/>
+                </a:solidFill>
+                <a:latin typeface="Open Sans"/>
+              </a:rPr>
+              <a:t>7.	Савиновский Д. А., Касперович М. А. Опробование метода извлечения лития из пластовых вод Восточной Сибири // Бурение и нефть. 2024. № 9. С. 54–57.</a:t>
+            </a:r>
+          </a:p>
+          <a:p>
+            <a:pPr marL="274320" indent="-274320">
+              <a:spcAft>
+                <a:spcPts val="300"/>
+              </a:spcAft>
+            </a:pPr>
+            <a:r>
+              <a:rPr sz="900" b="0" i="0">
+                <a:solidFill>
+                  <a:srgbClr val="262626"/>
+                </a:solidFill>
+                <a:latin typeface="Open Sans"/>
+              </a:rPr>
+              <a:t>8.	Chang X., Gong J., He L., Chen M. et al. High-performance Fe, Al and Pb co-doped H1.6Mn1.6O4 ion sieve synthesized from electrolytic manganese anode sludge for lithium recovery in natural gas produced water // Separation and Purification Technology. 2025. Vol. 370. Art. 133145.</a:t>
+            </a:r>
+          </a:p>
+        </p:txBody>
+      </p:sp>
+      <p:sp>
+        <p:nvSpPr>
+          <p:cNvPr id="5" name="TextBox 4"/>
+          <p:cNvSpPr txBox="1"/>
+          <p:nvPr/>
+        </p:nvSpPr>
+        <p:spPr>
+          <a:xfrm>
+            <a:off x="6277356" y="1874519"/>
+            <a:ext cx="5362956" cy="3977639"/>
+          </a:xfrm>
+          <a:prstGeom prst="rect">
+            <a:avLst/>
+          </a:prstGeom>
+          <a:noFill/>
+        </p:spPr>
+        <p:txBody>
+          <a:bodyPr wrap="square" lIns="0" rIns="0" tIns="0" bIns="0">
+            <a:spAutoFit/>
+          </a:bodyPr>
+          <a:lstStyle/>
+          <a:p>
+            <a:pPr marL="274320" indent="-274320">
+              <a:spcAft>
+                <a:spcPts val="300"/>
+              </a:spcAft>
+            </a:pPr>
+            <a:r>
+              <a:rPr sz="900" b="0" i="0">
+                <a:solidFill>
+                  <a:srgbClr val="262626"/>
+                </a:solidFill>
+                <a:latin typeface="Open Sans"/>
+              </a:rPr>
+              <a:t>9.	Farahbakhsh J., Arshadi F., Mofidi Z., Mohseni-Dargah M. et al. Direct lithium extraction: A new paradigm for lithium production and resource utilization // Desalination. 2024. Vol. 575. Art. 117249.</a:t>
+            </a:r>
+          </a:p>
+          <a:p>
+            <a:pPr marL="274320" indent="-274320">
+              <a:spcAft>
+                <a:spcPts val="300"/>
+              </a:spcAft>
+            </a:pPr>
+            <a:r>
+              <a:rPr sz="900" b="0" i="0">
+                <a:solidFill>
+                  <a:srgbClr val="262626"/>
+                </a:solidFill>
+                <a:latin typeface="Open Sans"/>
+              </a:rPr>
+              <a:t>10.	Knapik E., Rotko G., Marszałek M. Recovery of lithium from oilfield brines — current achievements and future perspectives: a mini review // Energies. 2023. Vol. 16, no. 18. Art. 6628.</a:t>
+            </a:r>
+          </a:p>
+          <a:p>
+            <a:pPr marL="274320" indent="-274320">
+              <a:spcAft>
+                <a:spcPts val="300"/>
+              </a:spcAft>
+            </a:pPr>
+            <a:r>
+              <a:rPr sz="900" b="0" i="0">
+                <a:solidFill>
+                  <a:srgbClr val="262626"/>
+                </a:solidFill>
+                <a:latin typeface="Open Sans"/>
+              </a:rPr>
+              <a:t>11.	Pan Y., Zhan W., Zhang W. Sustainable lithium extraction from produced water: Integrating membrane pretreatment and next-generation adsorbents // Journal of Environmental Management. 2025. Vol. 382. Art. 125343.</a:t>
+            </a:r>
+          </a:p>
+          <a:p>
+            <a:pPr marL="274320" indent="-274320">
+              <a:spcAft>
+                <a:spcPts val="300"/>
+              </a:spcAft>
+            </a:pPr>
+            <a:r>
+              <a:rPr sz="900" b="0" i="0">
+                <a:solidFill>
+                  <a:srgbClr val="262626"/>
+                </a:solidFill>
+                <a:latin typeface="Open Sans"/>
+              </a:rPr>
+              <a:t>12.	Seip A., Safari S., Pickup D. M., Chadwick A. V. et al. Lithium recovery from hydraulic fracturing flowback and produced water using a selective ion exchange sorbent // Chemical Engineering Journal. 2021. Vol. 426. Art. 130713.</a:t>
+            </a:r>
+          </a:p>
+          <a:p>
+            <a:pPr marL="274320" indent="-274320">
+              <a:spcAft>
+                <a:spcPts val="300"/>
+              </a:spcAft>
+            </a:pPr>
+            <a:r>
+              <a:rPr sz="900" b="0" i="0">
+                <a:solidFill>
+                  <a:srgbClr val="262626"/>
+                </a:solidFill>
+                <a:latin typeface="Open Sans"/>
+              </a:rPr>
+              <a:t>13.	Tian L., Liu Y., Tang P., Yang Y. et al. Lithium extraction from shale gas flowback and produced water using H1.33Mn1.67O4 adsorbent // Resources, Conservation and Recycling. 2022. Vol. 185. Art. 106476.</a:t>
+            </a:r>
+          </a:p>
+          <a:p>
+            <a:pPr marL="274320" indent="-274320">
+              <a:spcAft>
+                <a:spcPts val="300"/>
+              </a:spcAft>
+            </a:pPr>
+            <a:r>
+              <a:rPr sz="900" b="0" i="0">
+                <a:solidFill>
+                  <a:srgbClr val="262626"/>
+                </a:solidFill>
+                <a:latin typeface="Open Sans"/>
+              </a:rPr>
+              <a:t>14.	Vera M. L., Torres W. R., Galli C. I., Chagnes A., Flexer V. Environmental impact of direct lithium extraction from brines // Nature Reviews Earth &amp; Environment. 2023. Vol. 4, no. 3. P. 149–165.</a:t>
+            </a:r>
+          </a:p>
+          <a:p>
+            <a:pPr marL="274320" indent="-274320">
+              <a:spcAft>
+                <a:spcPts val="300"/>
+              </a:spcAft>
+            </a:pPr>
+            <a:r>
+              <a:rPr sz="900" b="0" i="0">
+                <a:solidFill>
+                  <a:srgbClr val="262626"/>
+                </a:solidFill>
+                <a:latin typeface="Open Sans"/>
+              </a:rPr>
+              <a:t>15.	U.S. Geological Survey. Lithium // Mineral Commodity Summaries 2026. Reston, VA, 2026.</a:t>
+            </a:r>
+          </a:p>
+          <a:p>
+            <a:pPr marL="274320" indent="-274320">
+              <a:spcAft>
+                <a:spcPts val="300"/>
+              </a:spcAft>
+            </a:pPr>
+            <a:r>
+              <a:rPr sz="900" b="0" i="0">
+                <a:solidFill>
+                  <a:srgbClr val="262626"/>
+                </a:solidFill>
+                <a:latin typeface="Open Sans"/>
+              </a:rPr>
+              <a:t>16.	Lithium prices // Benchmark Mineral Intelligence. URL: https://www.benchmarkminerals.com/lithium/prices (дата обращения: 25.09.2026).</a:t>
+            </a:r>
+          </a:p>
+        </p:txBody>
+      </p:sp>
+    </p:spTree>
+  </p:cSld>
+  <p:clrMapOvr>
+    <a:masterClrMapping/>
+  </p:clrMapOvr>
+</p:sld>
+</file>
+
 <file path=ppt/slides/slide2.xml><?xml version="1.0" encoding="utf-8"?>
 <p:sld xmlns:a="http://schemas.openxmlformats.org/drawingml/2006/main" xmlns:p="http://schemas.openxmlformats.org/presentationml/2006/main" xmlns:r="http://schemas.openxmlformats.org/officeDocument/2006/relationships">
   <p:cSld>
@@ -11893,7 +12350,7 @@
                 </a:solidFill>
                 <a:latin typeface="Open Sans"/>
               </a:rPr>
-              <a:t>2 / 16</a:t>
+              <a:t>2 / 17</a:t>
             </a:r>
           </a:p>
         </p:txBody>
@@ -12331,7 +12788,7 @@
                 </a:solidFill>
                 <a:latin typeface="Open Sans"/>
               </a:rPr>
-              <a:t>3 / 16</a:t>
+              <a:t>3 / 17</a:t>
             </a:r>
           </a:p>
         </p:txBody>
@@ -12788,7 +13245,7 @@
                 </a:solidFill>
                 <a:latin typeface="Open Sans"/>
               </a:rPr>
-              <a:t>4 / 16</a:t>
+              <a:t>4 / 17</a:t>
             </a:r>
           </a:p>
         </p:txBody>
@@ -13673,7 +14130,7 @@
                 </a:solidFill>
                 <a:latin typeface="Open Sans"/>
               </a:rPr>
-              <a:t>5 / 16</a:t>
+              <a:t>5 / 17</a:t>
             </a:r>
           </a:p>
         </p:txBody>
@@ -15311,7 +15768,7 @@
                 </a:solidFill>
                 <a:latin typeface="Open Sans"/>
               </a:rPr>
-              <a:t>6 / 16</a:t>
+              <a:t>6 / 17</a:t>
             </a:r>
           </a:p>
         </p:txBody>
@@ -17666,7 +18123,7 @@
                 </a:solidFill>
                 <a:latin typeface="Open Sans"/>
               </a:rPr>
-              <a:t>7 / 16</a:t>
+              <a:t>7 / 17</a:t>
             </a:r>
           </a:p>
         </p:txBody>
@@ -18106,7 +18563,7 @@
                 </a:solidFill>
                 <a:latin typeface="Open Sans"/>
               </a:rPr>
-              <a:t>8 / 16</a:t>
+              <a:t>8 / 17</a:t>
             </a:r>
           </a:p>
         </p:txBody>
@@ -19054,7 +19511,7 @@
                 </a:solidFill>
                 <a:latin typeface="Open Sans"/>
               </a:rPr>
-              <a:t>9 / 16</a:t>
+              <a:t>9 / 17</a:t>
             </a:r>
           </a:p>
         </p:txBody>

</xml_diff>